<commit_message>
Align section 16 with the actual 12-slide deck
</commit_message>
<xml_diff>
--- a/SAST_Agent_발표.pptx
+++ b/SAST_Agent_발표.pptx
@@ -148,7 +148,7 @@
     </p:spTree>
     <p:extLst>
       <p:ext uri="{BB962C8B-B14F-4D97-AF65-F5344CB8AC3E}">
-        <p14:creationId xmlns:p14="http://schemas.microsoft.com/office/powerpoint/2010/main" val="2582209875"/>
+        <p14:creationId xmlns:p14="http://schemas.microsoft.com/office/powerpoint/2010/main" val="127912697"/>
       </p:ext>
     </p:extLst>
   </p:cSld>
@@ -6086,7 +6086,7 @@
                 <a:ea typeface="Malgun Gothic" pitchFamily="34" charset="-122"/>
                 <a:cs typeface="Malgun Gothic" pitchFamily="34" charset="-120"/>
               </a:rPr>
-              <a:t>Chunker 115배치 · 조건부 호출 50.7% 절감 · 비가시 3,928/호출 제거</a:t>
+              <a:t>Chunker 115배치 · 조건부 호출 50.7% 절감 · 비가시 토큰 3,928 추정 → Run C inferred 0 관측</a:t>
             </a:r>
             <a:endParaRPr lang="en-US" sz="1050" dirty="0"/>
           </a:p>
@@ -13818,7 +13818,7 @@
                 <a:ea typeface="Malgun Gothic" pitchFamily="34" charset="-122"/>
                 <a:cs typeface="Malgun Gothic" pitchFamily="34" charset="-120"/>
               </a:rPr>
-              <a:t> — 일반 SAST는 strcpy/malloc 밀도로 정렬한다. vcos는 그런 API가 거의 없어 후순위로 밀린다. 그러나 "AI가 Race Condition을 미탐한다"는 한계를 시험하려면 반드시 먼저 스캔해야 한다.</a:t>
+              <a:t> — 위험 API(strcpy/malloc) 밀도 기반 접근에서는 vcos가 후순위로 밀릴 수 있다. 그러나 "AI가 Race Condition을 미탐한다"는 한계를 시험하려면 반드시 먼저 스캔해야 한다.</a:t>
             </a:r>
             <a:endParaRPr lang="en-US" sz="1100" dirty="0"/>
           </a:p>
@@ -14031,7 +14031,7 @@
         </p:nvSpPr>
         <p:spPr>
           <a:xfrm>
-            <a:off x="6492240" y="5010912"/>
+            <a:off x="6492240" y="4919472"/>
             <a:ext cx="5129784" cy="7315"/>
           </a:xfrm>
           <a:prstGeom prst="rect">
@@ -14063,7 +14063,7 @@
         </p:nvSpPr>
         <p:spPr>
           <a:xfrm>
-            <a:off x="6492240" y="4718304"/>
+            <a:off x="6492240" y="4626864"/>
             <a:ext cx="365760" cy="292608"/>
           </a:xfrm>
           <a:prstGeom prst="rect">
@@ -14102,7 +14102,7 @@
         </p:nvSpPr>
         <p:spPr>
           <a:xfrm>
-            <a:off x="6912864" y="4718304"/>
+            <a:off x="6912864" y="4626864"/>
             <a:ext cx="2651760" cy="292608"/>
           </a:xfrm>
           <a:prstGeom prst="rect">
@@ -14141,7 +14141,7 @@
         </p:nvSpPr>
         <p:spPr>
           <a:xfrm>
-            <a:off x="9601200" y="4718304"/>
+            <a:off x="9601200" y="4626864"/>
             <a:ext cx="2020824" cy="292608"/>
           </a:xfrm>
           <a:prstGeom prst="rect">
@@ -14180,7 +14180,7 @@
         </p:nvSpPr>
         <p:spPr>
           <a:xfrm>
-            <a:off x="6492240" y="5376672"/>
+            <a:off x="6492240" y="5248656"/>
             <a:ext cx="5129784" cy="7315"/>
           </a:xfrm>
           <a:prstGeom prst="rect">
@@ -14212,7 +14212,7 @@
         </p:nvSpPr>
         <p:spPr>
           <a:xfrm>
-            <a:off x="6492240" y="5084064"/>
+            <a:off x="6492240" y="4956048"/>
             <a:ext cx="365760" cy="292608"/>
           </a:xfrm>
           <a:prstGeom prst="rect">
@@ -14251,7 +14251,7 @@
         </p:nvSpPr>
         <p:spPr>
           <a:xfrm>
-            <a:off x="6912864" y="5084064"/>
+            <a:off x="6912864" y="4956048"/>
             <a:ext cx="2651760" cy="292608"/>
           </a:xfrm>
           <a:prstGeom prst="rect">
@@ -14290,7 +14290,7 @@
         </p:nvSpPr>
         <p:spPr>
           <a:xfrm>
-            <a:off x="9601200" y="5084064"/>
+            <a:off x="9601200" y="4956048"/>
             <a:ext cx="2020824" cy="292608"/>
           </a:xfrm>
           <a:prstGeom prst="rect">
@@ -14329,7 +14329,7 @@
         </p:nvSpPr>
         <p:spPr>
           <a:xfrm>
-            <a:off x="6492240" y="5742432"/>
+            <a:off x="6492240" y="5577840"/>
             <a:ext cx="5129784" cy="7315"/>
           </a:xfrm>
           <a:prstGeom prst="rect">
@@ -14361,7 +14361,7 @@
         </p:nvSpPr>
         <p:spPr>
           <a:xfrm>
-            <a:off x="6492240" y="5449824"/>
+            <a:off x="6492240" y="5285232"/>
             <a:ext cx="365760" cy="292608"/>
           </a:xfrm>
           <a:prstGeom prst="rect">
@@ -14400,7 +14400,7 @@
         </p:nvSpPr>
         <p:spPr>
           <a:xfrm>
-            <a:off x="6912864" y="5449824"/>
+            <a:off x="6912864" y="5285232"/>
             <a:ext cx="2651760" cy="292608"/>
           </a:xfrm>
           <a:prstGeom prst="rect">
@@ -14439,7 +14439,7 @@
         </p:nvSpPr>
         <p:spPr>
           <a:xfrm>
-            <a:off x="9601200" y="5449824"/>
+            <a:off x="9601200" y="5285232"/>
             <a:ext cx="2020824" cy="292608"/>
           </a:xfrm>
           <a:prstGeom prst="rect">
@@ -14478,7 +14478,7 @@
         </p:nvSpPr>
         <p:spPr>
           <a:xfrm>
-            <a:off x="6492240" y="6108192"/>
+            <a:off x="6492240" y="5907024"/>
             <a:ext cx="5129784" cy="7315"/>
           </a:xfrm>
           <a:prstGeom prst="rect">
@@ -14510,7 +14510,7 @@
         </p:nvSpPr>
         <p:spPr>
           <a:xfrm>
-            <a:off x="6492240" y="5815584"/>
+            <a:off x="6492240" y="5614416"/>
             <a:ext cx="365760" cy="292608"/>
           </a:xfrm>
           <a:prstGeom prst="rect">
@@ -14549,7 +14549,7 @@
         </p:nvSpPr>
         <p:spPr>
           <a:xfrm>
-            <a:off x="6912864" y="5815584"/>
+            <a:off x="6912864" y="5614416"/>
             <a:ext cx="2651760" cy="292608"/>
           </a:xfrm>
           <a:prstGeom prst="rect">
@@ -14588,7 +14588,7 @@
         </p:nvSpPr>
         <p:spPr>
           <a:xfrm>
-            <a:off x="9601200" y="5815584"/>
+            <a:off x="9601200" y="5614416"/>
             <a:ext cx="2020824" cy="292608"/>
           </a:xfrm>
           <a:prstGeom prst="rect">
@@ -14627,7 +14627,7 @@
         </p:nvSpPr>
         <p:spPr>
           <a:xfrm>
-            <a:off x="6492240" y="6473952"/>
+            <a:off x="6492240" y="6236208"/>
             <a:ext cx="5129784" cy="7315"/>
           </a:xfrm>
           <a:prstGeom prst="rect">
@@ -14659,7 +14659,7 @@
         </p:nvSpPr>
         <p:spPr>
           <a:xfrm>
-            <a:off x="6492240" y="6181344"/>
+            <a:off x="6492240" y="5943600"/>
             <a:ext cx="365760" cy="292608"/>
           </a:xfrm>
           <a:prstGeom prst="rect">
@@ -14698,7 +14698,7 @@
         </p:nvSpPr>
         <p:spPr>
           <a:xfrm>
-            <a:off x="6912864" y="6181344"/>
+            <a:off x="6912864" y="5943600"/>
             <a:ext cx="2651760" cy="292608"/>
           </a:xfrm>
           <a:prstGeom prst="rect">
@@ -14737,7 +14737,7 @@
         </p:nvSpPr>
         <p:spPr>
           <a:xfrm>
-            <a:off x="9601200" y="6181344"/>
+            <a:off x="9601200" y="5943600"/>
             <a:ext cx="2020824" cy="292608"/>
           </a:xfrm>
           <a:prstGeom prst="rect">
@@ -14762,7 +14762,7 @@
                 <a:ea typeface="Malgun Gothic" pitchFamily="34" charset="-122"/>
                 <a:cs typeface="Malgun Gothic" pitchFamily="34" charset="-120"/>
               </a:rPr>
-              <a:t>비가시 토큰 3,928/호출 제거</a:t>
+              <a:t>비가시 3,928 추정 → Run C 0</a:t>
             </a:r>
             <a:endParaRPr lang="en-US" sz="1000" dirty="0"/>
           </a:p>
@@ -14801,7 +14801,7 @@
                 <a:ea typeface="Malgun Gothic" pitchFamily="34" charset="-122"/>
                 <a:cs typeface="Malgun Gothic" pitchFamily="34" charset="-120"/>
               </a:rPr>
-              <a:t>50.7%는 동일 배치 관측 대조 — 두 실행은 모델이 달라(flash / flash-lite) 엄밀한 ON/OFF ablation은 아니다</a:t>
+              <a:t>50.7%는 동일 배치 관측 대조 — 두 실행의 모델이 달라(flash / flash-lite) 엄밀한 ON/OFF ablation은 아니다</a:t>
             </a:r>
             <a:endParaRPr lang="en-US" sz="1000" dirty="0"/>
           </a:p>

</xml_diff>

<commit_message>
Fix phase count (7→8) and CWE count (9→10) mismatches, sync PPT slide 6 with report §6.1
</commit_message>
<xml_diff>
--- a/SAST_Agent_발표.pptx
+++ b/SAST_Agent_발표.pptx
@@ -148,7 +148,7 @@
     </p:spTree>
     <p:extLst>
       <p:ext uri="{BB962C8B-B14F-4D97-AF65-F5344CB8AC3E}">
-        <p14:creationId xmlns:p14="http://schemas.microsoft.com/office/powerpoint/2010/main" val="1484565572"/>
+        <p14:creationId xmlns:p14="http://schemas.microsoft.com/office/powerpoint/2010/main" val="616258528"/>
       </p:ext>
     </p:extLst>
   </p:cSld>
@@ -2129,7 +2129,7 @@
               <a:buNone/>
             </a:pPr>
             <a:r>
-              <a:rPr lang="en-US" sz="950" dirty="0">
+              <a:rPr lang="en-US" sz="850" dirty="0">
                 <a:solidFill>
                   <a:srgbClr val="9AA7B6"/>
                 </a:solidFill>
@@ -2137,9 +2137,9 @@
                 <a:ea typeface="Courier New" pitchFamily="34" charset="-122"/>
                 <a:cs typeface="Courier New" pitchFamily="34" charset="-120"/>
               </a:rPr>
-              <a:t>agent_pipeline.py — B083 B097 B011</a:t>
-            </a:r>
-            <a:endParaRPr lang="en-US" sz="950" dirty="0"/>
+              <a:t>RUN A · RESULT SUMMARY (재구성, 실제 콘솔 캡처 아님)</a:t>
+            </a:r>
+            <a:endParaRPr lang="en-US" sz="850" dirty="0"/>
           </a:p>
         </p:txBody>
       </p:sp>
@@ -6882,7 +6882,7 @@
                 <a:ea typeface="Malgun Gothic" pitchFamily="34" charset="-122"/>
                 <a:cs typeface="Malgun Gothic" pitchFamily="34" charset="-120"/>
               </a:rPr>
-              <a:t>코드 자체를 컨텍스트로 제공 · Coverity lock_order 주석이 B011 단서</a:t>
+              <a:t>수동 검증에서 Coverity 주석 활용 · 자동 파이프라인은 재현 못함</a:t>
             </a:r>
             <a:endParaRPr lang="en-US" sz="1050" dirty="0"/>
           </a:p>
@@ -6921,7 +6921,7 @@
                 <a:ea typeface="Malgun Gothic" pitchFamily="34" charset="-122"/>
                 <a:cs typeface="Malgun Gothic" pitchFamily="34" charset="-120"/>
               </a:rPr>
-              <a:t>상당 부분 완화  </a:t>
+              <a:t>부분 완화  </a:t>
             </a:r>
             <a:r>
               <a:rPr lang="en-US" sz="1050" dirty="0">
@@ -6932,7 +6932,7 @@
                 <a:ea typeface="Malgun Gothic" pitchFamily="34" charset="-122"/>
                 <a:cs typeface="Malgun Gothic" pitchFamily="34" charset="-120"/>
               </a:rPr>
-              <a:t>●●●●○</a:t>
+              <a:t>●●●○○</a:t>
             </a:r>
             <a:endParaRPr lang="en-US" sz="1050" dirty="0"/>
           </a:p>
@@ -7257,7 +7257,7 @@
                 <a:ea typeface="Malgun Gothic" pitchFamily="34" charset="-122"/>
                 <a:cs typeface="Malgun Gothic" pitchFamily="34" charset="-120"/>
               </a:rPr>
-              <a:t>AGENDA · 10분 · 10 챕터</a:t>
+              <a:t>AGENDA · 10분 00초 · 12장 · 10 챕터</a:t>
             </a:r>
             <a:endParaRPr lang="en-US" sz="1200" dirty="0"/>
           </a:p>
@@ -7568,7 +7568,7 @@
         </p:nvSpPr>
         <p:spPr>
           <a:xfrm>
-            <a:off x="566928" y="3767328"/>
+            <a:off x="566928" y="3694176"/>
             <a:ext cx="11055096" cy="7315"/>
           </a:xfrm>
           <a:prstGeom prst="rect">
@@ -7600,7 +7600,7 @@
         </p:nvSpPr>
         <p:spPr>
           <a:xfrm>
-            <a:off x="566928" y="3310128"/>
+            <a:off x="566928" y="3236976"/>
             <a:ext cx="868680" cy="365760"/>
           </a:xfrm>
           <a:prstGeom prst="rect">
@@ -7625,7 +7625,7 @@
                 <a:ea typeface="Malgun Gothic" pitchFamily="34" charset="-122"/>
                 <a:cs typeface="Malgun Gothic" pitchFamily="34" charset="-120"/>
               </a:rPr>
-              <a:t>01·02</a:t>
+              <a:t>CH 01·02</a:t>
             </a:r>
             <a:endParaRPr lang="en-US" sz="1050" dirty="0"/>
           </a:p>
@@ -7639,7 +7639,7 @@
         </p:nvSpPr>
         <p:spPr>
           <a:xfrm>
-            <a:off x="1527048" y="3310128"/>
+            <a:off x="1527048" y="3236976"/>
             <a:ext cx="5760720" cy="365760"/>
           </a:xfrm>
           <a:prstGeom prst="rect">
@@ -7678,7 +7678,7 @@
         </p:nvSpPr>
         <p:spPr>
           <a:xfrm>
-            <a:off x="7424928" y="3310128"/>
+            <a:off x="7424928" y="3236976"/>
             <a:ext cx="3383280" cy="365760"/>
           </a:xfrm>
           <a:prstGeom prst="rect">
@@ -7717,7 +7717,7 @@
         </p:nvSpPr>
         <p:spPr>
           <a:xfrm>
-            <a:off x="10799064" y="3310128"/>
+            <a:off x="10799064" y="3236976"/>
             <a:ext cx="822960" cy="365760"/>
           </a:xfrm>
           <a:prstGeom prst="rect">
@@ -7742,7 +7742,7 @@
                 <a:ea typeface="Malgun Gothic" pitchFamily="34" charset="-122"/>
                 <a:cs typeface="Malgun Gothic" pitchFamily="34" charset="-120"/>
               </a:rPr>
-              <a:t>2:00</a:t>
+              <a:t>1:40</a:t>
             </a:r>
             <a:endParaRPr lang="en-US" sz="1200" dirty="0"/>
           </a:p>
@@ -7756,7 +7756,7 @@
         </p:nvSpPr>
         <p:spPr>
           <a:xfrm>
-            <a:off x="566928" y="4279392"/>
+            <a:off x="566928" y="4133088"/>
             <a:ext cx="11055096" cy="7315"/>
           </a:xfrm>
           <a:prstGeom prst="rect">
@@ -7788,7 +7788,7 @@
         </p:nvSpPr>
         <p:spPr>
           <a:xfrm>
-            <a:off x="566928" y="3822192"/>
+            <a:off x="566928" y="3675888"/>
             <a:ext cx="868680" cy="365760"/>
           </a:xfrm>
           <a:prstGeom prst="rect">
@@ -7813,7 +7813,7 @@
                 <a:ea typeface="Malgun Gothic" pitchFamily="34" charset="-122"/>
                 <a:cs typeface="Malgun Gothic" pitchFamily="34" charset="-120"/>
               </a:rPr>
-              <a:t>03·04</a:t>
+              <a:t>CH 03·04</a:t>
             </a:r>
             <a:endParaRPr lang="en-US" sz="1050" dirty="0"/>
           </a:p>
@@ -7827,7 +7827,7 @@
         </p:nvSpPr>
         <p:spPr>
           <a:xfrm>
-            <a:off x="1527048" y="3822192"/>
+            <a:off x="1527048" y="3675888"/>
             <a:ext cx="5760720" cy="365760"/>
           </a:xfrm>
           <a:prstGeom prst="rect">
@@ -7866,7 +7866,7 @@
         </p:nvSpPr>
         <p:spPr>
           <a:xfrm>
-            <a:off x="7424928" y="3822192"/>
+            <a:off x="7424928" y="3675888"/>
             <a:ext cx="3383280" cy="365760"/>
           </a:xfrm>
           <a:prstGeom prst="rect">
@@ -7905,7 +7905,7 @@
         </p:nvSpPr>
         <p:spPr>
           <a:xfrm>
-            <a:off x="10799064" y="3822192"/>
+            <a:off x="10799064" y="3675888"/>
             <a:ext cx="822960" cy="365760"/>
           </a:xfrm>
           <a:prstGeom prst="rect">
@@ -7930,7 +7930,7 @@
                 <a:ea typeface="Malgun Gothic" pitchFamily="34" charset="-122"/>
                 <a:cs typeface="Malgun Gothic" pitchFamily="34" charset="-120"/>
               </a:rPr>
-              <a:t>2:00</a:t>
+              <a:t>1:50</a:t>
             </a:r>
             <a:endParaRPr lang="en-US" sz="1200" dirty="0"/>
           </a:p>
@@ -7944,7 +7944,7 @@
         </p:nvSpPr>
         <p:spPr>
           <a:xfrm>
-            <a:off x="566928" y="4791456"/>
+            <a:off x="566928" y="4572000"/>
             <a:ext cx="11055096" cy="7315"/>
           </a:xfrm>
           <a:prstGeom prst="rect">
@@ -7976,7 +7976,7 @@
         </p:nvSpPr>
         <p:spPr>
           <a:xfrm>
-            <a:off x="566928" y="4334256"/>
+            <a:off x="566928" y="4114800"/>
             <a:ext cx="868680" cy="365760"/>
           </a:xfrm>
           <a:prstGeom prst="rect">
@@ -8001,7 +8001,7 @@
                 <a:ea typeface="Malgun Gothic" pitchFamily="34" charset="-122"/>
                 <a:cs typeface="Malgun Gothic" pitchFamily="34" charset="-120"/>
               </a:rPr>
-              <a:t>05</a:t>
+              <a:t>CH 05</a:t>
             </a:r>
             <a:endParaRPr lang="en-US" sz="1050" dirty="0"/>
           </a:p>
@@ -8015,7 +8015,7 @@
         </p:nvSpPr>
         <p:spPr>
           <a:xfrm>
-            <a:off x="1527048" y="4334256"/>
+            <a:off x="1527048" y="4114800"/>
             <a:ext cx="5760720" cy="365760"/>
           </a:xfrm>
           <a:prstGeom prst="rect">
@@ -8054,7 +8054,7 @@
         </p:nvSpPr>
         <p:spPr>
           <a:xfrm>
-            <a:off x="7424928" y="4334256"/>
+            <a:off x="7424928" y="4114800"/>
             <a:ext cx="3383280" cy="365760"/>
           </a:xfrm>
           <a:prstGeom prst="rect">
@@ -8093,7 +8093,7 @@
         </p:nvSpPr>
         <p:spPr>
           <a:xfrm>
-            <a:off x="10799064" y="4334256"/>
+            <a:off x="10799064" y="4114800"/>
             <a:ext cx="822960" cy="365760"/>
           </a:xfrm>
           <a:prstGeom prst="rect">
@@ -8118,7 +8118,7 @@
                 <a:ea typeface="Malgun Gothic" pitchFamily="34" charset="-122"/>
                 <a:cs typeface="Malgun Gothic" pitchFamily="34" charset="-120"/>
               </a:rPr>
-              <a:t>1:00</a:t>
+              <a:t>0:55</a:t>
             </a:r>
             <a:endParaRPr lang="en-US" sz="1200" dirty="0"/>
           </a:p>
@@ -8132,7 +8132,7 @@
         </p:nvSpPr>
         <p:spPr>
           <a:xfrm>
-            <a:off x="566928" y="4754880"/>
+            <a:off x="566928" y="4462272"/>
             <a:ext cx="11055096" cy="566928"/>
           </a:xfrm>
           <a:prstGeom prst="rect">
@@ -8164,7 +8164,7 @@
         </p:nvSpPr>
         <p:spPr>
           <a:xfrm>
-            <a:off x="566928" y="5303520"/>
+            <a:off x="566928" y="5010912"/>
             <a:ext cx="11055096" cy="7315"/>
           </a:xfrm>
           <a:prstGeom prst="rect">
@@ -8196,7 +8196,7 @@
         </p:nvSpPr>
         <p:spPr>
           <a:xfrm>
-            <a:off x="566928" y="4846320"/>
+            <a:off x="566928" y="4553712"/>
             <a:ext cx="868680" cy="365760"/>
           </a:xfrm>
           <a:prstGeom prst="rect">
@@ -8221,7 +8221,7 @@
                 <a:ea typeface="Malgun Gothic" pitchFamily="34" charset="-122"/>
                 <a:cs typeface="Malgun Gothic" pitchFamily="34" charset="-120"/>
               </a:rPr>
-              <a:t>06·07</a:t>
+              <a:t>CH 06</a:t>
             </a:r>
             <a:endParaRPr lang="en-US" sz="1050" dirty="0"/>
           </a:p>
@@ -8235,7 +8235,7 @@
         </p:nvSpPr>
         <p:spPr>
           <a:xfrm>
-            <a:off x="1527048" y="4846320"/>
+            <a:off x="1527048" y="4553712"/>
             <a:ext cx="5760720" cy="365760"/>
           </a:xfrm>
           <a:prstGeom prst="rect">
@@ -8274,7 +8274,7 @@
         </p:nvSpPr>
         <p:spPr>
           <a:xfrm>
-            <a:off x="7424928" y="4846320"/>
+            <a:off x="7424928" y="4553712"/>
             <a:ext cx="3383280" cy="365760"/>
           </a:xfrm>
           <a:prstGeom prst="rect">
@@ -8299,7 +8299,7 @@
                 <a:ea typeface="Malgun Gothic" pitchFamily="34" charset="-122"/>
                 <a:cs typeface="Malgun Gothic" pitchFamily="34" charset="-120"/>
               </a:rPr>
-              <a:t>의미적 환각 → v3 Evidence Contract.</a:t>
+              <a:t>의미적 환각을 코드가 놓쳤다.</a:t>
             </a:r>
             <a:endParaRPr lang="en-US" sz="1150" dirty="0"/>
           </a:p>
@@ -8313,7 +8313,7 @@
         </p:nvSpPr>
         <p:spPr>
           <a:xfrm>
-            <a:off x="10799064" y="4846320"/>
+            <a:off x="10799064" y="4553712"/>
             <a:ext cx="822960" cy="365760"/>
           </a:xfrm>
           <a:prstGeom prst="rect">
@@ -8338,7 +8338,7 @@
                 <a:ea typeface="Malgun Gothic" pitchFamily="34" charset="-122"/>
                 <a:cs typeface="Malgun Gothic" pitchFamily="34" charset="-120"/>
               </a:rPr>
-              <a:t>2:30</a:t>
+              <a:t>1:30</a:t>
             </a:r>
             <a:endParaRPr lang="en-US" sz="1200" dirty="0"/>
           </a:p>
@@ -8352,7 +8352,7 @@
         </p:nvSpPr>
         <p:spPr>
           <a:xfrm>
-            <a:off x="566928" y="5815584"/>
+            <a:off x="566928" y="5449824"/>
             <a:ext cx="11055096" cy="7315"/>
           </a:xfrm>
           <a:prstGeom prst="rect">
@@ -8384,7 +8384,7 @@
         </p:nvSpPr>
         <p:spPr>
           <a:xfrm>
-            <a:off x="566928" y="5358384"/>
+            <a:off x="566928" y="4992624"/>
             <a:ext cx="868680" cy="365760"/>
           </a:xfrm>
           <a:prstGeom prst="rect">
@@ -8409,7 +8409,7 @@
                 <a:ea typeface="Malgun Gothic" pitchFamily="34" charset="-122"/>
                 <a:cs typeface="Malgun Gothic" pitchFamily="34" charset="-120"/>
               </a:rPr>
-              <a:t>08</a:t>
+              <a:t>CH 07</a:t>
             </a:r>
             <a:endParaRPr lang="en-US" sz="1050" dirty="0"/>
           </a:p>
@@ -8423,7 +8423,7 @@
         </p:nvSpPr>
         <p:spPr>
           <a:xfrm>
-            <a:off x="1527048" y="5358384"/>
+            <a:off x="1527048" y="4992624"/>
             <a:ext cx="5760720" cy="365760"/>
           </a:xfrm>
           <a:prstGeom prst="rect">
@@ -8462,7 +8462,7 @@
         </p:nvSpPr>
         <p:spPr>
           <a:xfrm>
-            <a:off x="7424928" y="5358384"/>
+            <a:off x="7424928" y="4992624"/>
             <a:ext cx="3383280" cy="365760"/>
           </a:xfrm>
           <a:prstGeom prst="rect">
@@ -8501,7 +8501,7 @@
         </p:nvSpPr>
         <p:spPr>
           <a:xfrm>
-            <a:off x="10799064" y="5358384"/>
+            <a:off x="10799064" y="4992624"/>
             <a:ext cx="822960" cy="365760"/>
           </a:xfrm>
           <a:prstGeom prst="rect">
@@ -8526,7 +8526,7 @@
                 <a:ea typeface="Malgun Gothic" pitchFamily="34" charset="-122"/>
                 <a:cs typeface="Malgun Gothic" pitchFamily="34" charset="-120"/>
               </a:rPr>
-              <a:t>1:30</a:t>
+              <a:t>1:00</a:t>
             </a:r>
             <a:endParaRPr lang="en-US" sz="1200" dirty="0"/>
           </a:p>
@@ -8540,7 +8540,7 @@
         </p:nvSpPr>
         <p:spPr>
           <a:xfrm>
-            <a:off x="566928" y="6327648"/>
+            <a:off x="566928" y="5888736"/>
             <a:ext cx="11055096" cy="7315"/>
           </a:xfrm>
           <a:prstGeom prst="rect">
@@ -8572,6 +8572,194 @@
         </p:nvSpPr>
         <p:spPr>
           <a:xfrm>
+            <a:off x="566928" y="5431536"/>
+            <a:ext cx="868680" cy="365760"/>
+          </a:xfrm>
+          <a:prstGeom prst="rect">
+            <a:avLst/>
+          </a:prstGeom>
+          <a:noFill/>
+          <a:ln/>
+        </p:spPr>
+        <p:txBody>
+          <a:bodyPr wrap="square" lIns="0" tIns="0" rIns="0" bIns="0" rtlCol="0" anchor="ctr"/>
+          <a:lstStyle/>
+          <a:p>
+            <a:pPr marL="0" indent="0" algn="l">
+              <a:buNone/>
+            </a:pPr>
+            <a:r>
+              <a:rPr lang="en-US" sz="1050" kern="0" spc="100" dirty="0">
+                <a:solidFill>
+                  <a:srgbClr val="9AA7B6"/>
+                </a:solidFill>
+                <a:latin typeface="Malgun Gothic" pitchFamily="34" charset="0"/>
+                <a:ea typeface="Malgun Gothic" pitchFamily="34" charset="-122"/>
+                <a:cs typeface="Malgun Gothic" pitchFamily="34" charset="-120"/>
+              </a:rPr>
+              <a:t>CH 08</a:t>
+            </a:r>
+            <a:endParaRPr lang="en-US" sz="1050" dirty="0"/>
+          </a:p>
+        </p:txBody>
+      </p:sp>
+      <p:sp>
+        <p:nvSpPr>
+          <p:cNvPr id="38" name="Text 36"/>
+          <p:cNvSpPr/>
+          <p:nvPr/>
+        </p:nvSpPr>
+        <p:spPr>
+          <a:xfrm>
+            <a:off x="1527048" y="5431536"/>
+            <a:ext cx="5760720" cy="365760"/>
+          </a:xfrm>
+          <a:prstGeom prst="rect">
+            <a:avLst/>
+          </a:prstGeom>
+          <a:noFill/>
+          <a:ln/>
+        </p:spPr>
+        <p:txBody>
+          <a:bodyPr wrap="square" lIns="0" tIns="0" rIns="0" bIns="0" rtlCol="0" anchor="ctr"/>
+          <a:lstStyle/>
+          <a:p>
+            <a:pPr marL="0" indent="0" algn="l">
+              <a:buNone/>
+            </a:pPr>
+            <a:r>
+              <a:rPr lang="en-US" sz="1500" b="1" dirty="0">
+                <a:solidFill>
+                  <a:srgbClr val="0D1B2A"/>
+                </a:solidFill>
+                <a:latin typeface="Malgun Gothic" pitchFamily="34" charset="0"/>
+                <a:ea typeface="Malgun Gothic" pitchFamily="34" charset="-122"/>
+                <a:cs typeface="Malgun Gothic" pitchFamily="34" charset="-120"/>
+              </a:rPr>
+              <a:t>RESPONSE — v2 → v3 Evidence Contract</a:t>
+            </a:r>
+            <a:endParaRPr lang="en-US" sz="1500" dirty="0"/>
+          </a:p>
+        </p:txBody>
+      </p:sp>
+      <p:sp>
+        <p:nvSpPr>
+          <p:cNvPr id="39" name="Text 37"/>
+          <p:cNvSpPr/>
+          <p:nvPr/>
+        </p:nvSpPr>
+        <p:spPr>
+          <a:xfrm>
+            <a:off x="7424928" y="5431536"/>
+            <a:ext cx="3383280" cy="365760"/>
+          </a:xfrm>
+          <a:prstGeom prst="rect">
+            <a:avLst/>
+          </a:prstGeom>
+          <a:noFill/>
+          <a:ln/>
+        </p:spPr>
+        <p:txBody>
+          <a:bodyPr wrap="square" lIns="0" tIns="0" rIns="0" bIns="0" rtlCol="0" anchor="ctr"/>
+          <a:lstStyle/>
+          <a:p>
+            <a:pPr marL="0" indent="0" algn="l">
+              <a:buNone/>
+            </a:pPr>
+            <a:r>
+              <a:rPr lang="en-US" sz="1150" dirty="0">
+                <a:solidFill>
+                  <a:srgbClr val="6B7A8F"/>
+                </a:solidFill>
+                <a:latin typeface="Malgun Gothic" pitchFamily="34" charset="0"/>
+                <a:ea typeface="Malgun Gothic" pitchFamily="34" charset="-122"/>
+                <a:cs typeface="Malgun Gothic" pitchFamily="34" charset="-120"/>
+              </a:rPr>
+              <a:t>존재성 검증에서 근거 검증으로.</a:t>
+            </a:r>
+            <a:endParaRPr lang="en-US" sz="1150" dirty="0"/>
+          </a:p>
+        </p:txBody>
+      </p:sp>
+      <p:sp>
+        <p:nvSpPr>
+          <p:cNvPr id="40" name="Text 38"/>
+          <p:cNvSpPr/>
+          <p:nvPr/>
+        </p:nvSpPr>
+        <p:spPr>
+          <a:xfrm>
+            <a:off x="10799064" y="5431536"/>
+            <a:ext cx="822960" cy="365760"/>
+          </a:xfrm>
+          <a:prstGeom prst="rect">
+            <a:avLst/>
+          </a:prstGeom>
+          <a:noFill/>
+          <a:ln/>
+        </p:spPr>
+        <p:txBody>
+          <a:bodyPr wrap="square" lIns="0" tIns="0" rIns="0" bIns="0" rtlCol="0" anchor="ctr"/>
+          <a:lstStyle/>
+          <a:p>
+            <a:pPr marL="0" indent="0" algn="r">
+              <a:buNone/>
+            </a:pPr>
+            <a:r>
+              <a:rPr lang="en-US" sz="1200" b="1" dirty="0">
+                <a:solidFill>
+                  <a:srgbClr val="0D1B2A"/>
+                </a:solidFill>
+                <a:latin typeface="Malgun Gothic" pitchFamily="34" charset="0"/>
+                <a:ea typeface="Malgun Gothic" pitchFamily="34" charset="-122"/>
+                <a:cs typeface="Malgun Gothic" pitchFamily="34" charset="-120"/>
+              </a:rPr>
+              <a:t>0:50</a:t>
+            </a:r>
+            <a:endParaRPr lang="en-US" sz="1200" dirty="0"/>
+          </a:p>
+        </p:txBody>
+      </p:sp>
+      <p:sp>
+        <p:nvSpPr>
+          <p:cNvPr id="41" name="Shape 39"/>
+          <p:cNvSpPr/>
+          <p:nvPr/>
+        </p:nvSpPr>
+        <p:spPr>
+          <a:xfrm>
+            <a:off x="566928" y="6327648"/>
+            <a:ext cx="11055096" cy="7315"/>
+          </a:xfrm>
+          <a:prstGeom prst="rect">
+            <a:avLst/>
+          </a:prstGeom>
+          <a:solidFill>
+            <a:srgbClr val="DDE3EA"/>
+          </a:solidFill>
+          <a:ln w="12700">
+            <a:solidFill>
+              <a:srgbClr val="333333"/>
+            </a:solidFill>
+            <a:prstDash val="solid"/>
+          </a:ln>
+        </p:spPr>
+        <p:txBody>
+          <a:bodyPr/>
+          <a:lstStyle/>
+          <a:p>
+            <a:endParaRPr lang="ko-KR" altLang="en-US"/>
+          </a:p>
+        </p:txBody>
+      </p:sp>
+      <p:sp>
+        <p:nvSpPr>
+          <p:cNvPr id="42" name="Text 40"/>
+          <p:cNvSpPr/>
+          <p:nvPr/>
+        </p:nvSpPr>
+        <p:spPr>
+          <a:xfrm>
             <a:off x="566928" y="5870448"/>
             <a:ext cx="868680" cy="365760"/>
           </a:xfrm>
@@ -8597,7 +8785,7 @@
                 <a:ea typeface="Malgun Gothic" pitchFamily="34" charset="-122"/>
                 <a:cs typeface="Malgun Gothic" pitchFamily="34" charset="-120"/>
               </a:rPr>
-              <a:t>09·10</a:t>
+              <a:t>CH 09·10</a:t>
             </a:r>
             <a:endParaRPr lang="en-US" sz="1050" dirty="0"/>
           </a:p>
@@ -8605,7 +8793,7 @@
       </p:sp>
       <p:sp>
         <p:nvSpPr>
-          <p:cNvPr id="38" name="Text 36"/>
+          <p:cNvPr id="43" name="Text 41"/>
           <p:cNvSpPr/>
           <p:nvPr/>
         </p:nvSpPr>
@@ -8644,7 +8832,7 @@
       </p:sp>
       <p:sp>
         <p:nvSpPr>
-          <p:cNvPr id="39" name="Text 37"/>
+          <p:cNvPr id="44" name="Text 42"/>
           <p:cNvSpPr/>
           <p:nvPr/>
         </p:nvSpPr>
@@ -8683,7 +8871,7 @@
       </p:sp>
       <p:sp>
         <p:nvSpPr>
-          <p:cNvPr id="40" name="Text 38"/>
+          <p:cNvPr id="45" name="Text 43"/>
           <p:cNvSpPr/>
           <p:nvPr/>
         </p:nvSpPr>
@@ -8714,7 +8902,7 @@
                 <a:ea typeface="Malgun Gothic" pitchFamily="34" charset="-122"/>
                 <a:cs typeface="Malgun Gothic" pitchFamily="34" charset="-120"/>
               </a:rPr>
-              <a:t>1:00</a:t>
+              <a:t>1:45</a:t>
             </a:r>
             <a:endParaRPr lang="en-US" sz="1200" dirty="0"/>
           </a:p>
@@ -8722,7 +8910,7 @@
       </p:sp>
       <p:sp>
         <p:nvSpPr>
-          <p:cNvPr id="41" name="Text 39"/>
+          <p:cNvPr id="46" name="Text 44"/>
           <p:cNvSpPr/>
           <p:nvPr/>
         </p:nvSpPr>
@@ -8753,7 +8941,7 @@
                 <a:ea typeface="Malgun Gothic" pitchFamily="34" charset="-122"/>
                 <a:cs typeface="Malgun Gothic" pitchFamily="34" charset="-120"/>
               </a:rPr>
-              <a:t>실패 사례(챕터 06)에 가장 긴 시간을 배정 — 이 프로젝트의 기여가 거기 있기 때문</a:t>
+              <a:t>합계 10분 00초 · 실패 사례(CH06)에 가장 긴 1분 30초를 배정 — 이 프로젝트의 기여가 거기 있기 때문</a:t>
             </a:r>
             <a:endParaRPr lang="en-US" sz="1000" dirty="0"/>
           </a:p>
@@ -12674,7 +12862,7 @@
                 <a:ea typeface="Malgun Gothic" pitchFamily="34" charset="-122"/>
                 <a:cs typeface="Malgun Gothic" pitchFamily="34" charset="-120"/>
               </a:rPr>
-              <a:t>목적함수 정반대. 6단계 상태.</a:t>
+              <a:t>목적함수 정반대. 5단계 검증 상태.</a:t>
             </a:r>
             <a:endParaRPr lang="en-US" sz="1050" dirty="0"/>
           </a:p>
@@ -14127,7 +14315,7 @@
                 <a:ea typeface="Malgun Gothic" pitchFamily="34" charset="-122"/>
                 <a:cs typeface="Malgun Gothic" pitchFamily="34" charset="-120"/>
               </a:rPr>
-              <a:t>비-코드 파일 배제</a:t>
+              <a:t>C 분석 대상 외 배제</a:t>
             </a:r>
             <a:endParaRPr lang="en-US" sz="1150" dirty="0"/>
           </a:p>
@@ -14425,7 +14613,7 @@
                 <a:ea typeface="Malgun Gothic" pitchFamily="34" charset="-122"/>
                 <a:cs typeface="Malgun Gothic" pitchFamily="34" charset="-120"/>
               </a:rPr>
-              <a:t>Rule Engine 선행</a:t>
+              <a:t>출력 스키마 제한</a:t>
             </a:r>
             <a:endParaRPr lang="en-US" sz="1150" dirty="0"/>
           </a:p>
@@ -14464,7 +14652,7 @@
                 <a:ea typeface="Malgun Gothic" pitchFamily="34" charset="-122"/>
                 <a:cs typeface="Malgun Gothic" pitchFamily="34" charset="-120"/>
               </a:rPr>
-              <a:t>Cppcheck 0토큰 힌트</a:t>
+              <a:t>Evidence 2문장·5줄 이내 강제</a:t>
             </a:r>
             <a:endParaRPr lang="en-US" sz="1000" dirty="0"/>
           </a:p>
@@ -15089,7 +15277,7 @@
                 <a:ea typeface="Malgun Gothic" pitchFamily="34" charset="-122"/>
                 <a:cs typeface="Malgun Gothic" pitchFamily="34" charset="-120"/>
               </a:rPr>
-              <a:t>"CONFIRMED만 3건"을 의도적으로 피했다.</a:t>
+              <a:t>서로 다른 공격 표면을 대표하는 3개 배치를 실행 전 선정했다.</a:t>
             </a:r>
             <a:endParaRPr lang="en-US" sz="2700" dirty="0"/>
           </a:p>
@@ -16235,7 +16423,7 @@
                 <a:ea typeface="Malgun Gothic" pitchFamily="34" charset="-122"/>
                 <a:cs typeface="Malgun Gothic" pitchFamily="34" charset="-120"/>
               </a:rPr>
-              <a:t>총 160,814 토큰 · usage_metadata 실측 · 서로 다른 판정 유형이 나오도록 3개 배치를 의도적으로 선정</a:t>
+              <a:t>총 160,814 토큰 · usage_metadata 실측 · 서로 다른 공격 표면을 대표하도록 선정(DT 파서 / MP4 파서 / 동시성) — 판정 유형은 실행 결과로 관측된 것</a:t>
             </a:r>
             <a:endParaRPr lang="en-US" sz="1000" dirty="0"/>
           </a:p>

</xml_diff>